<commit_message>
updating class 6 ppt
</commit_message>
<xml_diff>
--- a/docs/lectures/in-class_activities/class_6.pptx
+++ b/docs/lectures/in-class_activities/class_6.pptx
@@ -204,7 +204,7 @@
           <a:p>
             <a:fld id="{6AC7DB66-C6D6-B24E-B345-FA3772C924EA}" type="datetimeFigureOut">
               <a:rPr lang="en-US" smtClean="0"/>
-              <a:t>10/13/25</a:t>
+              <a:t>10/14/26</a:t>
             </a:fld>
             <a:endParaRPr lang="en-US"/>
           </a:p>
@@ -1312,7 +1312,7 @@
           <a:p>
             <a:fld id="{21DDE3A9-9D48-7D40-AF95-520AE186EA5D}" type="datetimeFigureOut">
               <a:rPr lang="en-US" smtClean="0"/>
-              <a:t>10/13/25</a:t>
+              <a:t>10/14/26</a:t>
             </a:fld>
             <a:endParaRPr lang="en-US"/>
           </a:p>
@@ -1510,7 +1510,7 @@
           <a:p>
             <a:fld id="{21DDE3A9-9D48-7D40-AF95-520AE186EA5D}" type="datetimeFigureOut">
               <a:rPr lang="en-US" smtClean="0"/>
-              <a:t>10/13/25</a:t>
+              <a:t>10/14/26</a:t>
             </a:fld>
             <a:endParaRPr lang="en-US"/>
           </a:p>
@@ -1718,7 +1718,7 @@
           <a:p>
             <a:fld id="{21DDE3A9-9D48-7D40-AF95-520AE186EA5D}" type="datetimeFigureOut">
               <a:rPr lang="en-US" smtClean="0"/>
-              <a:t>10/13/25</a:t>
+              <a:t>10/14/26</a:t>
             </a:fld>
             <a:endParaRPr lang="en-US"/>
           </a:p>
@@ -1916,7 +1916,7 @@
           <a:p>
             <a:fld id="{21DDE3A9-9D48-7D40-AF95-520AE186EA5D}" type="datetimeFigureOut">
               <a:rPr lang="en-US" smtClean="0"/>
-              <a:t>10/13/25</a:t>
+              <a:t>10/14/26</a:t>
             </a:fld>
             <a:endParaRPr lang="en-US"/>
           </a:p>
@@ -2191,7 +2191,7 @@
           <a:p>
             <a:fld id="{21DDE3A9-9D48-7D40-AF95-520AE186EA5D}" type="datetimeFigureOut">
               <a:rPr lang="en-US" smtClean="0"/>
-              <a:t>10/13/25</a:t>
+              <a:t>10/14/26</a:t>
             </a:fld>
             <a:endParaRPr lang="en-US"/>
           </a:p>
@@ -2456,7 +2456,7 @@
           <a:p>
             <a:fld id="{21DDE3A9-9D48-7D40-AF95-520AE186EA5D}" type="datetimeFigureOut">
               <a:rPr lang="en-US" smtClean="0"/>
-              <a:t>10/13/25</a:t>
+              <a:t>10/14/26</a:t>
             </a:fld>
             <a:endParaRPr lang="en-US"/>
           </a:p>
@@ -2868,7 +2868,7 @@
           <a:p>
             <a:fld id="{21DDE3A9-9D48-7D40-AF95-520AE186EA5D}" type="datetimeFigureOut">
               <a:rPr lang="en-US" smtClean="0"/>
-              <a:t>10/13/25</a:t>
+              <a:t>10/14/26</a:t>
             </a:fld>
             <a:endParaRPr lang="en-US"/>
           </a:p>
@@ -3009,7 +3009,7 @@
           <a:p>
             <a:fld id="{21DDE3A9-9D48-7D40-AF95-520AE186EA5D}" type="datetimeFigureOut">
               <a:rPr lang="en-US" smtClean="0"/>
-              <a:t>10/13/25</a:t>
+              <a:t>10/14/26</a:t>
             </a:fld>
             <a:endParaRPr lang="en-US"/>
           </a:p>
@@ -3122,7 +3122,7 @@
           <a:p>
             <a:fld id="{21DDE3A9-9D48-7D40-AF95-520AE186EA5D}" type="datetimeFigureOut">
               <a:rPr lang="en-US" smtClean="0"/>
-              <a:t>10/13/25</a:t>
+              <a:t>10/14/26</a:t>
             </a:fld>
             <a:endParaRPr lang="en-US"/>
           </a:p>
@@ -3433,7 +3433,7 @@
           <a:p>
             <a:fld id="{21DDE3A9-9D48-7D40-AF95-520AE186EA5D}" type="datetimeFigureOut">
               <a:rPr lang="en-US" smtClean="0"/>
-              <a:t>10/13/25</a:t>
+              <a:t>10/14/26</a:t>
             </a:fld>
             <a:endParaRPr lang="en-US"/>
           </a:p>
@@ -3721,7 +3721,7 @@
           <a:p>
             <a:fld id="{21DDE3A9-9D48-7D40-AF95-520AE186EA5D}" type="datetimeFigureOut">
               <a:rPr lang="en-US" smtClean="0"/>
-              <a:t>10/13/25</a:t>
+              <a:t>10/14/26</a:t>
             </a:fld>
             <a:endParaRPr lang="en-US"/>
           </a:p>
@@ -3962,7 +3962,7 @@
           <a:p>
             <a:fld id="{21DDE3A9-9D48-7D40-AF95-520AE186EA5D}" type="datetimeFigureOut">
               <a:rPr lang="en-US" smtClean="0"/>
-              <a:t>10/13/25</a:t>
+              <a:t>10/14/26</a:t>
             </a:fld>
             <a:endParaRPr lang="en-US"/>
           </a:p>
@@ -4620,7 +4620,7 @@
                 <a:latin typeface="Avenir"/>
                 <a:cs typeface="Avenir"/>
               </a:rPr>
-              <a:t>Ponder on your own (5 m) then share with the class (5 m).</a:t>
+              <a:t>Ponder on your own (2 m) then share with the class (5 m).</a:t>
             </a:r>
           </a:p>
         </p:txBody>
@@ -5255,7 +5255,7 @@
                 <a:latin typeface="Avenir"/>
                 <a:cs typeface="Avenir"/>
               </a:rPr>
-              <a:t>Ponder on your own (5 m), discuss with a partner (5 m), then share with the class (5 m).</a:t>
+              <a:t>Ponder on your own (3 m), discuss with a partner (5 m), then share with the class (5 m).</a:t>
             </a:r>
           </a:p>
         </p:txBody>
@@ -5711,8 +5711,8 @@
         </p:nvSpPr>
         <p:spPr bwMode="auto">
           <a:xfrm>
-            <a:off x="3558774" y="5203918"/>
-            <a:ext cx="8490345" cy="1477328"/>
+            <a:off x="3558774" y="5354387"/>
+            <a:ext cx="8490345" cy="1015663"/>
           </a:xfrm>
           <a:prstGeom prst="rect">
             <a:avLst/>
@@ -5740,21 +5740,19 @@
                 <a:latin typeface="Avenir"/>
                 <a:cs typeface="Avenir"/>
               </a:rPr>
-              <a:t>Google Doc on your own (5 m), then discuss and make a debate plan with your </a:t>
-            </a:r>
-            <a:r>
-              <a:rPr lang="en-US" sz="3000" b="1">
-                <a:latin typeface="Avenir"/>
-                <a:cs typeface="Avenir"/>
-              </a:rPr>
-              <a:t>group        (</a:t>
-            </a:r>
+              <a:t>Ponder on your own (2 m), then white board </a:t>
+            </a:r>
+          </a:p>
+          <a:p>
+            <a:pPr>
+              <a:defRPr/>
+            </a:pPr>
             <a:r>
               <a:rPr lang="en-US" sz="3000" b="1" dirty="0">
                 <a:latin typeface="Avenir"/>
                 <a:cs typeface="Avenir"/>
               </a:rPr>
-              <a:t>5 m), then debate with the class (5 m).</a:t>
+              <a:t>with your group (5 m).</a:t>
             </a:r>
           </a:p>
         </p:txBody>

</xml_diff>